<commit_message>
sprawko 2 - biblioteki radomskie 1/3 - crppl
</commit_message>
<xml_diff>
--- a/Statystyki_bibliotek_radomskich/Wybrane statystyki bibliotek radomskich.pptx
+++ b/Statystyki_bibliotek_radomskich/Wybrane statystyki bibliotek radomskich.pptx
@@ -5,27 +5,28 @@
     <p:sldMasterId id="2147483648" r:id="rId1"/>
   </p:sldMasterIdLst>
   <p:notesMasterIdLst>
-    <p:notesMasterId r:id="rId20"/>
+    <p:notesMasterId r:id="rId21"/>
   </p:notesMasterIdLst>
   <p:sldIdLst>
     <p:sldId id="256" r:id="rId2"/>
-    <p:sldId id="272" r:id="rId3"/>
-    <p:sldId id="257" r:id="rId4"/>
-    <p:sldId id="258" r:id="rId5"/>
-    <p:sldId id="271" r:id="rId6"/>
-    <p:sldId id="259" r:id="rId7"/>
-    <p:sldId id="260" r:id="rId8"/>
-    <p:sldId id="263" r:id="rId9"/>
-    <p:sldId id="270" r:id="rId10"/>
-    <p:sldId id="262" r:id="rId11"/>
-    <p:sldId id="269" r:id="rId12"/>
-    <p:sldId id="264" r:id="rId13"/>
-    <p:sldId id="268" r:id="rId14"/>
-    <p:sldId id="273" r:id="rId15"/>
-    <p:sldId id="261" r:id="rId16"/>
-    <p:sldId id="266" r:id="rId17"/>
-    <p:sldId id="265" r:id="rId18"/>
-    <p:sldId id="274" r:id="rId19"/>
+    <p:sldId id="275" r:id="rId3"/>
+    <p:sldId id="272" r:id="rId4"/>
+    <p:sldId id="257" r:id="rId5"/>
+    <p:sldId id="258" r:id="rId6"/>
+    <p:sldId id="271" r:id="rId7"/>
+    <p:sldId id="259" r:id="rId8"/>
+    <p:sldId id="260" r:id="rId9"/>
+    <p:sldId id="263" r:id="rId10"/>
+    <p:sldId id="270" r:id="rId11"/>
+    <p:sldId id="262" r:id="rId12"/>
+    <p:sldId id="269" r:id="rId13"/>
+    <p:sldId id="264" r:id="rId14"/>
+    <p:sldId id="268" r:id="rId15"/>
+    <p:sldId id="273" r:id="rId16"/>
+    <p:sldId id="261" r:id="rId17"/>
+    <p:sldId id="266" r:id="rId18"/>
+    <p:sldId id="265" r:id="rId19"/>
+    <p:sldId id="274" r:id="rId20"/>
   </p:sldIdLst>
   <p:sldSz cx="12192000" cy="6858000"/>
   <p:notesSz cx="6858000" cy="9144000"/>
@@ -124,6 +125,11 @@
       </a:defRPr>
     </a:lvl9pPr>
   </p:defaultTextStyle>
+  <p:extLst>
+    <p:ext uri="{EFAFB233-063F-42B5-8137-9DF3F51BA10A}">
+      <p15:sldGuideLst xmlns:p15="http://schemas.microsoft.com/office/powerpoint/2012/main"/>
+    </p:ext>
+  </p:extLst>
 </p:presentation>
 </file>
 
@@ -541,7 +547,7 @@
           <a:p>
             <a:fld id="{E3EF9190-787C-4587-AD44-9B12D2F76160}" type="slidenum">
               <a:rPr lang="pl-PL" smtClean="0"/>
-              <a:t>5</a:t>
+              <a:t>6</a:t>
             </a:fld>
             <a:endParaRPr lang="pl-PL"/>
           </a:p>
@@ -3895,6 +3901,102 @@
           <p:cNvPr id="2" name="Tytuł 1">
             <a:extLst>
               <a:ext uri="{FF2B5EF4-FFF2-40B4-BE49-F238E27FC236}">
+                <a16:creationId xmlns:a16="http://schemas.microsoft.com/office/drawing/2014/main" id="{12A15025-DBF4-5ED6-4A0E-2AB60FAFC6EA}"/>
+              </a:ext>
+            </a:extLst>
+          </p:cNvPr>
+          <p:cNvSpPr>
+            <a:spLocks noGrp="1"/>
+          </p:cNvSpPr>
+          <p:nvPr>
+            <p:ph type="title"/>
+          </p:nvPr>
+        </p:nvSpPr>
+        <p:spPr/>
+        <p:txBody>
+          <a:bodyPr/>
+          <a:lstStyle/>
+          <a:p>
+            <a:r>
+              <a:rPr lang="pl-PL" dirty="0"/>
+              <a:t>Pracownicy na przestrzeni lat</a:t>
+            </a:r>
+          </a:p>
+        </p:txBody>
+      </p:sp>
+      <p:pic>
+        <p:nvPicPr>
+          <p:cNvPr id="5" name="Symbol zastępczy zawartości 4">
+            <a:extLst>
+              <a:ext uri="{FF2B5EF4-FFF2-40B4-BE49-F238E27FC236}">
+                <a16:creationId xmlns:a16="http://schemas.microsoft.com/office/drawing/2014/main" id="{EB29D3BE-9EFB-E649-7947-A86464434996}"/>
+              </a:ext>
+            </a:extLst>
+          </p:cNvPr>
+          <p:cNvPicPr>
+            <a:picLocks noGrp="1" noChangeAspect="1"/>
+          </p:cNvPicPr>
+          <p:nvPr>
+            <p:ph idx="1"/>
+          </p:nvPr>
+        </p:nvPicPr>
+        <p:blipFill>
+          <a:blip r:embed="rId2">
+            <a:extLst>
+              <a:ext uri="{28A0092B-C50C-407E-A947-70E740481C1C}">
+                <a14:useLocalDpi xmlns:a14="http://schemas.microsoft.com/office/drawing/2010/main" val="0"/>
+              </a:ext>
+            </a:extLst>
+          </a:blip>
+          <a:stretch>
+            <a:fillRect/>
+          </a:stretch>
+        </p:blipFill>
+        <p:spPr>
+          <a:xfrm>
+            <a:off x="2158868" y="1997074"/>
+            <a:ext cx="7874264" cy="4724559"/>
+          </a:xfrm>
+          <a:prstGeom prst="rect">
+            <a:avLst/>
+          </a:prstGeom>
+        </p:spPr>
+      </p:pic>
+    </p:spTree>
+    <p:extLst>
+      <p:ext uri="{BB962C8B-B14F-4D97-AF65-F5344CB8AC3E}">
+        <p14:creationId xmlns:p14="http://schemas.microsoft.com/office/powerpoint/2010/main" val="3493918921"/>
+      </p:ext>
+    </p:extLst>
+  </p:cSld>
+  <p:clrMapOvr>
+    <a:masterClrMapping/>
+  </p:clrMapOvr>
+</p:sld>
+</file>
+
+<file path=ppt/slides/slide11.xml><?xml version="1.0" encoding="utf-8"?>
+<p:sld xmlns:a="http://schemas.openxmlformats.org/drawingml/2006/main" xmlns:r="http://schemas.openxmlformats.org/officeDocument/2006/relationships" xmlns:p="http://schemas.openxmlformats.org/presentationml/2006/main">
+  <p:cSld>
+    <p:spTree>
+      <p:nvGrpSpPr>
+        <p:cNvPr id="1" name=""/>
+        <p:cNvGrpSpPr/>
+        <p:nvPr/>
+      </p:nvGrpSpPr>
+      <p:grpSpPr>
+        <a:xfrm>
+          <a:off x="0" y="0"/>
+          <a:ext cx="0" cy="0"/>
+          <a:chOff x="0" y="0"/>
+          <a:chExt cx="0" cy="0"/>
+        </a:xfrm>
+      </p:grpSpPr>
+      <p:sp>
+        <p:nvSpPr>
+          <p:cNvPr id="2" name="Tytuł 1">
+            <a:extLst>
+              <a:ext uri="{FF2B5EF4-FFF2-40B4-BE49-F238E27FC236}">
                 <a16:creationId xmlns:a16="http://schemas.microsoft.com/office/drawing/2014/main" id="{1FD3911B-040E-ADAE-F21C-AD024A4FC787}"/>
               </a:ext>
             </a:extLst>
@@ -3967,7 +4069,7 @@
 </p:sld>
 </file>
 
-<file path=ppt/slides/slide11.xml><?xml version="1.0" encoding="utf-8"?>
+<file path=ppt/slides/slide12.xml><?xml version="1.0" encoding="utf-8"?>
 <p:sld xmlns:a="http://schemas.openxmlformats.org/drawingml/2006/main" xmlns:r="http://schemas.openxmlformats.org/officeDocument/2006/relationships" xmlns:p="http://schemas.openxmlformats.org/presentationml/2006/main">
   <p:cSld>
     <p:spTree>
@@ -4063,7 +4165,7 @@
 </p:sld>
 </file>
 
-<file path=ppt/slides/slide12.xml><?xml version="1.0" encoding="utf-8"?>
+<file path=ppt/slides/slide13.xml><?xml version="1.0" encoding="utf-8"?>
 <p:sld xmlns:a="http://schemas.openxmlformats.org/drawingml/2006/main" xmlns:r="http://schemas.openxmlformats.org/officeDocument/2006/relationships" xmlns:p="http://schemas.openxmlformats.org/presentationml/2006/main">
   <p:cSld>
     <p:spTree>
@@ -4103,7 +4205,15 @@
           <a:p>
             <a:r>
               <a:rPr lang="pl-PL" dirty="0"/>
-              <a:t>Liczba wypożyczeni zewnętrznych w bibliotekach publicznych</a:t>
+              <a:t>Liczba </a:t>
+            </a:r>
+            <a:r>
+              <a:rPr lang="pl-PL" dirty="0" err="1"/>
+              <a:t>wypożyczeń</a:t>
+            </a:r>
+            <a:r>
+              <a:rPr lang="pl-PL" dirty="0"/>
+              <a:t> zewnętrznych w bibliotekach publicznych</a:t>
             </a:r>
           </a:p>
         </p:txBody>
@@ -4159,7 +4269,7 @@
 </p:sld>
 </file>
 
-<file path=ppt/slides/slide13.xml><?xml version="1.0" encoding="utf-8"?>
+<file path=ppt/slides/slide14.xml><?xml version="1.0" encoding="utf-8"?>
 <p:sld xmlns:a="http://schemas.openxmlformats.org/drawingml/2006/main" xmlns:r="http://schemas.openxmlformats.org/officeDocument/2006/relationships" xmlns:p="http://schemas.openxmlformats.org/presentationml/2006/main">
   <p:cSld>
     <p:spTree>
@@ -4255,7 +4365,7 @@
 </p:sld>
 </file>
 
-<file path=ppt/slides/slide14.xml><?xml version="1.0" encoding="utf-8"?>
+<file path=ppt/slides/slide15.xml><?xml version="1.0" encoding="utf-8"?>
 <p:sld xmlns:a="http://schemas.openxmlformats.org/drawingml/2006/main" xmlns:r="http://schemas.openxmlformats.org/officeDocument/2006/relationships" xmlns:p="http://schemas.openxmlformats.org/presentationml/2006/main">
   <p:cSld>
     <p:spTree>
@@ -4351,7 +4461,7 @@
 </p:sld>
 </file>
 
-<file path=ppt/slides/slide15.xml><?xml version="1.0" encoding="utf-8"?>
+<file path=ppt/slides/slide16.xml><?xml version="1.0" encoding="utf-8"?>
 <p:sld xmlns:a="http://schemas.openxmlformats.org/drawingml/2006/main" xmlns:r="http://schemas.openxmlformats.org/officeDocument/2006/relationships" xmlns:p="http://schemas.openxmlformats.org/presentationml/2006/main">
   <p:cSld>
     <p:spTree>
@@ -4445,7 +4555,7 @@
 </p:sld>
 </file>
 
-<file path=ppt/slides/slide16.xml><?xml version="1.0" encoding="utf-8"?>
+<file path=ppt/slides/slide17.xml><?xml version="1.0" encoding="utf-8"?>
 <p:sld xmlns:a="http://schemas.openxmlformats.org/drawingml/2006/main" xmlns:r="http://schemas.openxmlformats.org/officeDocument/2006/relationships" xmlns:p="http://schemas.openxmlformats.org/presentationml/2006/main">
   <p:cSld>
     <p:spTree>
@@ -4541,7 +4651,7 @@
 </p:sld>
 </file>
 
-<file path=ppt/slides/slide17.xml><?xml version="1.0" encoding="utf-8"?>
+<file path=ppt/slides/slide18.xml><?xml version="1.0" encoding="utf-8"?>
 <p:sld xmlns:a="http://schemas.openxmlformats.org/drawingml/2006/main" xmlns:r="http://schemas.openxmlformats.org/officeDocument/2006/relationships" xmlns:p="http://schemas.openxmlformats.org/presentationml/2006/main">
   <p:cSld>
     <p:spTree>
@@ -4637,7 +4747,7 @@
 </p:sld>
 </file>
 
-<file path=ppt/slides/slide18.xml><?xml version="1.0" encoding="utf-8"?>
+<file path=ppt/slides/slide19.xml><?xml version="1.0" encoding="utf-8"?>
 <p:sld xmlns:a="http://schemas.openxmlformats.org/drawingml/2006/main" xmlns:r="http://schemas.openxmlformats.org/officeDocument/2006/relationships" xmlns:p="http://schemas.openxmlformats.org/presentationml/2006/main">
   <p:cSld>
     <p:spTree>
@@ -4755,7 +4865,7 @@
           <p:cNvPr id="2" name="Tytuł 1">
             <a:extLst>
               <a:ext uri="{FF2B5EF4-FFF2-40B4-BE49-F238E27FC236}">
-                <a16:creationId xmlns:a16="http://schemas.microsoft.com/office/drawing/2014/main" id="{BF230A87-FC3C-1FA6-BF71-6A0D47920473}"/>
+                <a16:creationId xmlns:a16="http://schemas.microsoft.com/office/drawing/2014/main" id="{6BE0E523-4A09-B3BF-1958-E7F448A38761}"/>
               </a:ext>
             </a:extLst>
           </p:cNvPr>
@@ -4783,6 +4893,113 @@
           <p:cNvPr id="3" name="Symbol zastępczy zawartości 2">
             <a:extLst>
               <a:ext uri="{FF2B5EF4-FFF2-40B4-BE49-F238E27FC236}">
+                <a16:creationId xmlns:a16="http://schemas.microsoft.com/office/drawing/2014/main" id="{C3E1765C-16B1-5BEC-AF23-566190D9B7EB}"/>
+              </a:ext>
+            </a:extLst>
+          </p:cNvPr>
+          <p:cNvSpPr>
+            <a:spLocks noGrp="1"/>
+          </p:cNvSpPr>
+          <p:nvPr>
+            <p:ph idx="1"/>
+          </p:nvPr>
+        </p:nvSpPr>
+        <p:spPr/>
+        <p:txBody>
+          <a:bodyPr/>
+          <a:lstStyle/>
+          <a:p>
+            <a:r>
+              <a:rPr lang="pl-PL" dirty="0"/>
+              <a:t>Dane zostały zbierane dla bibliotek publicznych i prywatnych należących do powiatu miasta Radom;</a:t>
+            </a:r>
+          </a:p>
+          <a:p>
+            <a:r>
+              <a:rPr lang="pl-PL" dirty="0"/>
+              <a:t>Dane zostały zebrane w przedziale 1996 - 2025 roku;</a:t>
+            </a:r>
+          </a:p>
+          <a:p>
+            <a:r>
+              <a:rPr lang="pl-PL" dirty="0"/>
+              <a:t>Ostatnia aktualizacja danych nastąpiła 02.06.2025 roku;</a:t>
+            </a:r>
+          </a:p>
+          <a:p>
+            <a:r>
+              <a:rPr lang="pl-PL" dirty="0"/>
+              <a:t>Część danych została zbierana od wybranych lat, nie od samego początku - występują puste rekordy;</a:t>
+            </a:r>
+          </a:p>
+          <a:p>
+            <a:endParaRPr lang="pl-PL" dirty="0"/>
+          </a:p>
+        </p:txBody>
+      </p:sp>
+    </p:spTree>
+    <p:extLst>
+      <p:ext uri="{BB962C8B-B14F-4D97-AF65-F5344CB8AC3E}">
+        <p14:creationId xmlns:p14="http://schemas.microsoft.com/office/powerpoint/2010/main" val="2787217106"/>
+      </p:ext>
+    </p:extLst>
+  </p:cSld>
+  <p:clrMapOvr>
+    <a:masterClrMapping/>
+  </p:clrMapOvr>
+</p:sld>
+</file>
+
+<file path=ppt/slides/slide3.xml><?xml version="1.0" encoding="utf-8"?>
+<p:sld xmlns:a="http://schemas.openxmlformats.org/drawingml/2006/main" xmlns:r="http://schemas.openxmlformats.org/officeDocument/2006/relationships" xmlns:p="http://schemas.openxmlformats.org/presentationml/2006/main">
+  <p:cSld>
+    <p:spTree>
+      <p:nvGrpSpPr>
+        <p:cNvPr id="1" name=""/>
+        <p:cNvGrpSpPr/>
+        <p:nvPr/>
+      </p:nvGrpSpPr>
+      <p:grpSpPr>
+        <a:xfrm>
+          <a:off x="0" y="0"/>
+          <a:ext cx="0" cy="0"/>
+          <a:chOff x="0" y="0"/>
+          <a:chExt cx="0" cy="0"/>
+        </a:xfrm>
+      </p:grpSpPr>
+      <p:sp>
+        <p:nvSpPr>
+          <p:cNvPr id="2" name="Tytuł 1">
+            <a:extLst>
+              <a:ext uri="{FF2B5EF4-FFF2-40B4-BE49-F238E27FC236}">
+                <a16:creationId xmlns:a16="http://schemas.microsoft.com/office/drawing/2014/main" id="{BF230A87-FC3C-1FA6-BF71-6A0D47920473}"/>
+              </a:ext>
+            </a:extLst>
+          </p:cNvPr>
+          <p:cNvSpPr>
+            <a:spLocks noGrp="1"/>
+          </p:cNvSpPr>
+          <p:nvPr>
+            <p:ph type="title"/>
+          </p:nvPr>
+        </p:nvSpPr>
+        <p:spPr/>
+        <p:txBody>
+          <a:bodyPr/>
+          <a:lstStyle/>
+          <a:p>
+            <a:r>
+              <a:rPr lang="pl-PL" dirty="0"/>
+              <a:t>Opis ważnych pojęć</a:t>
+            </a:r>
+          </a:p>
+        </p:txBody>
+      </p:sp>
+      <p:sp>
+        <p:nvSpPr>
+          <p:cNvPr id="3" name="Symbol zastępczy zawartości 2">
+            <a:extLst>
+              <a:ext uri="{FF2B5EF4-FFF2-40B4-BE49-F238E27FC236}">
                 <a16:creationId xmlns:a16="http://schemas.microsoft.com/office/drawing/2014/main" id="{02E38675-1D13-890B-1A9F-9F94528C94E2}"/>
               </a:ext>
             </a:extLst>
@@ -4801,15 +5018,23 @@
           <a:p>
             <a:pPr algn="just"/>
             <a:r>
+              <a:rPr lang="pl-PL" b="1" dirty="0"/>
+              <a:t>Biblioteka publiczna</a:t>
+            </a:r>
+            <a:r>
               <a:rPr lang="pl-PL" dirty="0"/>
-              <a:t>Biblioteka publiczna – zarejestrowana biblioteka należąca do Miejskiej Biblioteki Publicznej w Radomiu. Stan aktualny – 12 filii.</a:t>
+              <a:t> – zarejestrowana biblioteka należąca do Miejskiej Biblioteki Publicznej w Radomiu. Stan aktualny – 12 filii.</a:t>
             </a:r>
           </a:p>
           <a:p>
             <a:pPr algn="just"/>
             <a:r>
+              <a:rPr lang="pl-PL" b="1" dirty="0"/>
+              <a:t>Biblioteka prywatna</a:t>
+            </a:r>
+            <a:r>
               <a:rPr lang="pl-PL" dirty="0"/>
-              <a:t>Biblioteka prywatna - dotyczą placówek pedagogicznych, naukowych, fachowych, fachowo-beletrystycznych, ośrodków informacji naukowej, technicznej i ekonomicznej (INTE), towarzystwa naukowego. Gromadzone corocznie od 2011, wcześniej co 2 lata.</a:t>
+              <a:t> - dotyczą placówek pedagogicznych, naukowych, fachowych, fachowo-beletrystycznych, ośrodków informacji naukowej, technicznej i ekonomicznej (INTE), towarzystwa naukowego. Gromadzone corocznie od 2011, wcześniej co 2 lata.</a:t>
             </a:r>
           </a:p>
           <a:p>
@@ -4830,7 +5055,7 @@
 </p:sld>
 </file>
 
-<file path=ppt/slides/slide3.xml><?xml version="1.0" encoding="utf-8"?>
+<file path=ppt/slides/slide4.xml><?xml version="1.0" encoding="utf-8"?>
 <p:sld xmlns:a="http://schemas.openxmlformats.org/drawingml/2006/main" xmlns:r="http://schemas.openxmlformats.org/officeDocument/2006/relationships" xmlns:p="http://schemas.openxmlformats.org/presentationml/2006/main">
   <p:cSld>
     <p:spTree>
@@ -4926,7 +5151,7 @@
 </p:sld>
 </file>
 
-<file path=ppt/slides/slide4.xml><?xml version="1.0" encoding="utf-8"?>
+<file path=ppt/slides/slide5.xml><?xml version="1.0" encoding="utf-8"?>
 <p:sld xmlns:a="http://schemas.openxmlformats.org/drawingml/2006/main" xmlns:r="http://schemas.openxmlformats.org/officeDocument/2006/relationships" xmlns:p="http://schemas.openxmlformats.org/presentationml/2006/main">
   <p:cSld>
     <p:spTree>
@@ -5020,7 +5245,7 @@
 </p:sld>
 </file>
 
-<file path=ppt/slides/slide5.xml><?xml version="1.0" encoding="utf-8"?>
+<file path=ppt/slides/slide6.xml><?xml version="1.0" encoding="utf-8"?>
 <p:sld xmlns:a="http://schemas.openxmlformats.org/drawingml/2006/main" xmlns:r="http://schemas.openxmlformats.org/officeDocument/2006/relationships" xmlns:p="http://schemas.openxmlformats.org/presentationml/2006/main">
   <p:cSld>
     <p:spTree>
@@ -5116,7 +5341,7 @@
 </p:sld>
 </file>
 
-<file path=ppt/slides/slide6.xml><?xml version="1.0" encoding="utf-8"?>
+<file path=ppt/slides/slide7.xml><?xml version="1.0" encoding="utf-8"?>
 <p:sld xmlns:a="http://schemas.openxmlformats.org/drawingml/2006/main" xmlns:r="http://schemas.openxmlformats.org/officeDocument/2006/relationships" xmlns:p="http://schemas.openxmlformats.org/presentationml/2006/main">
   <p:cSld>
     <p:spTree>
@@ -5149,7 +5374,12 @@
             <p:ph type="title"/>
           </p:nvPr>
         </p:nvSpPr>
-        <p:spPr/>
+        <p:spPr>
+          <a:xfrm>
+            <a:off x="838200" y="365125"/>
+            <a:ext cx="10515600" cy="1325563"/>
+          </a:xfrm>
+        </p:spPr>
         <p:txBody>
           <a:bodyPr/>
           <a:lstStyle/>
@@ -5212,7 +5442,7 @@
 </p:sld>
 </file>
 
-<file path=ppt/slides/slide7.xml><?xml version="1.0" encoding="utf-8"?>
+<file path=ppt/slides/slide8.xml><?xml version="1.0" encoding="utf-8"?>
 <p:sld xmlns:a="http://schemas.openxmlformats.org/drawingml/2006/main" xmlns:r="http://schemas.openxmlformats.org/officeDocument/2006/relationships" xmlns:p="http://schemas.openxmlformats.org/presentationml/2006/main">
   <p:cSld>
     <p:spTree>
@@ -5308,7 +5538,7 @@
 </p:sld>
 </file>
 
-<file path=ppt/slides/slide8.xml><?xml version="1.0" encoding="utf-8"?>
+<file path=ppt/slides/slide9.xml><?xml version="1.0" encoding="utf-8"?>
 <p:sld xmlns:a="http://schemas.openxmlformats.org/drawingml/2006/main" xmlns:r="http://schemas.openxmlformats.org/officeDocument/2006/relationships" xmlns:p="http://schemas.openxmlformats.org/presentationml/2006/main">
   <p:cSld>
     <p:spTree>
@@ -5395,102 +5625,6 @@
     <p:extLst>
       <p:ext uri="{BB962C8B-B14F-4D97-AF65-F5344CB8AC3E}">
         <p14:creationId xmlns:p14="http://schemas.microsoft.com/office/powerpoint/2010/main" val="2186575380"/>
-      </p:ext>
-    </p:extLst>
-  </p:cSld>
-  <p:clrMapOvr>
-    <a:masterClrMapping/>
-  </p:clrMapOvr>
-</p:sld>
-</file>
-
-<file path=ppt/slides/slide9.xml><?xml version="1.0" encoding="utf-8"?>
-<p:sld xmlns:a="http://schemas.openxmlformats.org/drawingml/2006/main" xmlns:r="http://schemas.openxmlformats.org/officeDocument/2006/relationships" xmlns:p="http://schemas.openxmlformats.org/presentationml/2006/main">
-  <p:cSld>
-    <p:spTree>
-      <p:nvGrpSpPr>
-        <p:cNvPr id="1" name=""/>
-        <p:cNvGrpSpPr/>
-        <p:nvPr/>
-      </p:nvGrpSpPr>
-      <p:grpSpPr>
-        <a:xfrm>
-          <a:off x="0" y="0"/>
-          <a:ext cx="0" cy="0"/>
-          <a:chOff x="0" y="0"/>
-          <a:chExt cx="0" cy="0"/>
-        </a:xfrm>
-      </p:grpSpPr>
-      <p:sp>
-        <p:nvSpPr>
-          <p:cNvPr id="2" name="Tytuł 1">
-            <a:extLst>
-              <a:ext uri="{FF2B5EF4-FFF2-40B4-BE49-F238E27FC236}">
-                <a16:creationId xmlns:a16="http://schemas.microsoft.com/office/drawing/2014/main" id="{12A15025-DBF4-5ED6-4A0E-2AB60FAFC6EA}"/>
-              </a:ext>
-            </a:extLst>
-          </p:cNvPr>
-          <p:cNvSpPr>
-            <a:spLocks noGrp="1"/>
-          </p:cNvSpPr>
-          <p:nvPr>
-            <p:ph type="title"/>
-          </p:nvPr>
-        </p:nvSpPr>
-        <p:spPr/>
-        <p:txBody>
-          <a:bodyPr/>
-          <a:lstStyle/>
-          <a:p>
-            <a:r>
-              <a:rPr lang="pl-PL" dirty="0"/>
-              <a:t>Pracownicy na przestrzeni lat</a:t>
-            </a:r>
-          </a:p>
-        </p:txBody>
-      </p:sp>
-      <p:pic>
-        <p:nvPicPr>
-          <p:cNvPr id="5" name="Symbol zastępczy zawartości 4">
-            <a:extLst>
-              <a:ext uri="{FF2B5EF4-FFF2-40B4-BE49-F238E27FC236}">
-                <a16:creationId xmlns:a16="http://schemas.microsoft.com/office/drawing/2014/main" id="{EB29D3BE-9EFB-E649-7947-A86464434996}"/>
-              </a:ext>
-            </a:extLst>
-          </p:cNvPr>
-          <p:cNvPicPr>
-            <a:picLocks noGrp="1" noChangeAspect="1"/>
-          </p:cNvPicPr>
-          <p:nvPr>
-            <p:ph idx="1"/>
-          </p:nvPr>
-        </p:nvPicPr>
-        <p:blipFill>
-          <a:blip r:embed="rId2">
-            <a:extLst>
-              <a:ext uri="{28A0092B-C50C-407E-A947-70E740481C1C}">
-                <a14:useLocalDpi xmlns:a14="http://schemas.microsoft.com/office/drawing/2010/main" val="0"/>
-              </a:ext>
-            </a:extLst>
-          </a:blip>
-          <a:stretch>
-            <a:fillRect/>
-          </a:stretch>
-        </p:blipFill>
-        <p:spPr>
-          <a:xfrm>
-            <a:off x="2158868" y="1997074"/>
-            <a:ext cx="7874264" cy="4724559"/>
-          </a:xfrm>
-          <a:prstGeom prst="rect">
-            <a:avLst/>
-          </a:prstGeom>
-        </p:spPr>
-      </p:pic>
-    </p:spTree>
-    <p:extLst>
-      <p:ext uri="{BB962C8B-B14F-4D97-AF65-F5344CB8AC3E}">
-        <p14:creationId xmlns:p14="http://schemas.microsoft.com/office/powerpoint/2010/main" val="3493918921"/>
       </p:ext>
     </p:extLst>
   </p:cSld>

</xml_diff>